<commit_message>
Patch the class intro deck with deep-research fact checks.
Nalepa leakage numbers, Purdue 220-band remainder, Pavia no-data strips, and an explicit note that sinusoidal λ-PE is a stand-in for LESSViT SSRoPE.
</commit_message>
<xml_diff>
--- a/docs/SSFT-Wave_class_intro.pptx
+++ b/docs/SSFT-Wave_class_intro.pptx
@@ -774,7 +774,7 @@
           <a:p>
             <a:r>
               <a:rPr lang="en-US" dirty="0"/>
-              <a:t>Novelty is the combination and the evaluation protocol, not a new attention operator. Be explicit that 516k is the paper’s count; our D=64 reconstruction may land ~0.16–0.23M.</a:t>
+              <a:t>Deep-research check: tied embed and λ-PE are already in LESSViT §2; SSRoPE is rotary, not additive sinusoids. Do not claim a new mechanism. Claim the graft onto SSFT fusion plus a class-scale protocol. Paper 516k vs our D=64 reconstruction ~0.16–0.23M — report ours.</a:t>
             </a:r>
             <a:endParaRPr lang="en-US" dirty="0"/>
           </a:p>
@@ -862,7 +862,7 @@
           <a:p>
             <a:r>
               <a:rPr lang="en-US" dirty="0"/>
-              <a:t>If asked why not EuroSAT RGB: wrong sensor. Stretch later is 13-band EuroSAT-MS / Sentinel-2, not this intro.</a:t>
+              <a:t>GIC lists 224 bands then 200 after water-absorption drop; Purdue’s Site 3 release is a 220-band cube, and 220−20=200. Prefer ‘220-band product, commonly 200 bands.’ Pavia 610×340 is after discarding no-data strips from 610×610.</a:t>
             </a:r>
             <a:endParaRPr lang="en-US" dirty="0"/>
           </a:p>
@@ -2711,7 +2711,7 @@
                 <a:ea typeface="Arial" pitchFamily="34" charset="-122"/>
                 <a:cs typeface="Arial" pitchFamily="34" charset="-120"/>
               </a:rPr>
-              <a:t>Random-pixel splits leak 8-connected neighbors into train and test. Indian Pines is also badly imbalanced (Oats n=20 vs Soybean-mintill n=2455).</a:t>
+              <a:t>Random-pixel splits leak neighbors into train and test. On Indian Pines a 3×3 window already covers ~31% of test pixels at 5% train, ~86% at 25%. 3D-CNN OA can drop ~37% under a true spatial split.</a:t>
             </a:r>
             <a:endParaRPr lang="en-US" sz="1400" dirty="0"/>
           </a:p>
@@ -2750,7 +2750,7 @@
                 <a:ea typeface="Arial" pitchFamily="34" charset="-122"/>
                 <a:cs typeface="Arial" pitchFamily="34" charset="-120"/>
               </a:rPr>
-              <a:t>LESSViT §1–§2 (Si et al., arXiv:2605.18541): spectral configuration shift. Spatial leakage: HSIC disjoint-sampling literature (random vs region splits).</a:t>
+              <a:t>LESSViT §1–§2 (arXiv:2605.18541). Leakage numbers: Nalepa, Myller, Kawulok, arXiv:1811.03707 / IEEE GRSL 2019.</a:t>
             </a:r>
             <a:endParaRPr lang="en-US" sz="1000" dirty="0"/>
           </a:p>
@@ -3626,7 +3626,7 @@
                 <a:ea typeface="Georgia" pitchFamily="34" charset="-122"/>
                 <a:cs typeface="Georgia" pitchFamily="34" charset="-120"/>
               </a:rPr>
-              <a:t>One surgical change</a:t>
+              <a:t>One surgical graft</a:t>
             </a:r>
             <a:endParaRPr lang="en-US" sz="1800" dirty="0"/>
           </a:p>
@@ -3665,7 +3665,7 @@
                 <a:ea typeface="Arial" pitchFamily="34" charset="-122"/>
                 <a:cs typeface="Arial" pitchFamily="34" charset="-120"/>
               </a:rPr>
-              <a:t>Copy SSFT §3 (D=64, s=8, 1 spectral MHSA, 1 spatial block, 1 fusion). Replace P ∈ R^{C×D} with sinusoidal 1D PE on λ in nm. Tie every C-mixing layer so C is not a weight shape.</a:t>
+              <a:t>Copy SSFT §3. Steal two LESSViT ideas (tied projection, wavelength PE) — not LESS Attention, not SSRoPE. Sinusoidal λ-PE stands in for their rotary encoding. The graft plus the band-drop protocol is the class experiment, not a new operator.</a:t>
             </a:r>
             <a:endParaRPr lang="en-US" sz="1500" dirty="0"/>
           </a:p>
@@ -4054,7 +4054,7 @@
                 <a:ea typeface="Arial" pitchFamily="34" charset="-122"/>
                 <a:cs typeface="Arial" pitchFamily="34" charset="-120"/>
               </a:rPr>
-              <a:t>AVIRIS  ·  145×145  ·  16 classes  ·  ~200 bands after dropping water-absorption channels  ·  ~400–2500 nm  ·  10,249 labeled pixels, highly imbalanced.</a:t>
+              <a:t>AVIRIS  ·  145×145  ·  16 classes  ·  Purdue 220-band cube, commonly 200 after dropping water-absorption bands  ·  ~400–2500 nm  ·  10,249 labeled pixels (Oats 20 vs Soybean-mintill 2455).</a:t>
             </a:r>
             <a:endParaRPr lang="en-US" sz="1400" dirty="0"/>
           </a:p>
@@ -4235,7 +4235,7 @@
                 <a:ea typeface="Arial" pitchFamily="34" charset="-122"/>
                 <a:cs typeface="Arial" pitchFamily="34" charset="-120"/>
               </a:rPr>
-              <a:t>ROSIS  ·  610×340  ·  9 urban classes  ·  103 bands  ·  430–860 nm. Same patch and split rules. Confirms the protocol is not Indian Pines-specific.</a:t>
+              <a:t>ROSIS  ·  9 urban classes  ·  103 bands  ·  ~430–860 nm (sources vary 850/860). Captured 610×610; after discarding no-data strips the usual cube is 610×340×103. Same patch and split rules.</a:t>
             </a:r>
             <a:endParaRPr lang="en-US" sz="1400" dirty="0"/>
           </a:p>
@@ -6561,7 +6561,7 @@
                 <a:ea typeface="Arial" pitchFamily="34" charset="-122"/>
                 <a:cs typeface="Arial" pitchFamily="34" charset="-120"/>
               </a:rPr>
-              <a:t>Protocol adapted from LESSViT §3.1 (train C120 VNIR+; test ID / SWIR+ / disjoint / full-C), shrunk to Indian Pines / Pavia U.</a:t>
+              <a:t>Relative-drop protocol from LESSViT §3.1. Random ~50% drop is our class operationalization. SSFT itself has no band-drop protocol.</a:t>
             </a:r>
             <a:endParaRPr lang="en-US" sz="1000" dirty="0"/>
           </a:p>

</xml_diff>